<commit_message>
chore: clean the UART
</commit_message>
<xml_diff>
--- a/APEX_presentation.pptx
+++ b/APEX_presentation.pptx
@@ -507,7 +507,11 @@
           <a:p>
             <a:r>
               <a:rPr lang="en-US" dirty="0"/>
-              <a:t>Bonjour, notre projet s'appelle APEX — comme l'apogée d'un saut. En une phrase : un boîtier qui mesure la hauteur de votre détente. Posez le décor sur la trajectoire à droite : décollage, apogée à 0 g, réception.</a:t>
+              <a:t>SLIDE TITRE (1min30)
+• APEX = point le plus haut d'une trajectoire
+• Montrer la courbe : décollage → apogée → réception
+• Le boîtier ne voit RIEN (ni sol, ni corps) → pourtant affiche la hauteur
+• Annonce plan : physique + STM32 + enquête de debug en 3 actes</a:t>
             </a:r>
             <a:endParaRPr lang="en-US" dirty="0"/>
           </a:p>
@@ -595,7 +599,13 @@
           <a:p>
             <a:r>
               <a:rPr lang="en-US" dirty="0"/>
-              <a:t>Insistez sur l'usage : régler un objectif, sauter, lire le verdict, vibrer si gagné. Le point à marteler : APEX ne voit ni le corps ni le sol — il déduit tout du temps passé en apesanteur. C'est contre-intuitif et ça accroche.</a:t>
+              <a:t>SLIDE 01 — APPLICATION (2min30)
+• Juge d'explosivité de poche
+• 4 étapes : RÉGLER (potentiomètre) → SAUTER → MESURER (7-seg) → VIBRER (victoire)
+• Question clé : comment mesurer SANS GPS ni caméra ?
+• Réponse : en l'air = CHUTE LIBRE → accéléromètre ressent ≈ 0 g (apesanteur, comme ISS)
+• Le pari : CHRONOMÉTRER LE SILENCE → plus longtemps en l'air = plus haut
+• 3 chiffres : ≈0g / 1 ms résolution / verdict 7-seg</a:t>
             </a:r>
             <a:endParaRPr lang="en-US" dirty="0"/>
           </a:p>
@@ -683,7 +693,16 @@
           <a:p>
             <a:r>
               <a:rPr lang="en-US" dirty="0"/>
-              <a:t>Présentez le matériel comme un orchestre : chaque périphérique a un rôle unique. Justifiez les deux interruptions obligatoires (boutons + timer). Terminez sur : le timer est le cœur — ça prépare le premier défi.</a:t>
+              <a:t>SLIDE 02 — SOLUTION TECHNIQUE (3min30)
+• Plateforme : NUCLEO-L152RE (Cortex-M3) + shield IKS01A3 + carte ISEN32
+• LSM6DSO (I2C) = l'œil → sent l'apesanteur et l'impact
+• MAX7219 (SPI) = afficheur → 2 bus séparés = zéro conflit
+• Potentiomètre (ADC) = réglage objectif en cm
+• TIM6 (IT) = LE CŒUR → 1 ms exacte, toute la mesure dépend de lui ← insister !
+• Boutons (GPIO + IT) = armer/valider → avec TIM6 = les 2 IT du CDC
+• Moteur vibreur (GPIO) = victoire
+• UART printf = fenêtre debug (rôle décisif plus tard)
+• Transition : "sur le papier c'est propre... la réalité fut différente"</a:t>
             </a:r>
             <a:endParaRPr lang="en-US" dirty="0"/>
           </a:p>
@@ -771,7 +790,21 @@
           <a:p>
             <a:r>
               <a:rPr lang="en-US" dirty="0"/>
-              <a:t>Votre meilleur moment : racontez les trois pannes comme une enquête. Le faux coupable (timer ARR=0), l'adresse fantôme (PB6/7 vs PB8/9), l'instant manqué (échantillonnage lent). L'UART printf a été le stéthoscope. Un jury adore la démarche plus que le code parfait.</a:t>
+              <a:t>SLIDE 03 — ENQUÊTE DEBUG (4min30) ← MOMENT FORT, ton narratif
+AFFAIRE 1 — LE FAUX COUPABLE
+• Symptôme : boutons muets → on vérifie pull-up, anti-rebond... innocents !
+• Vrai coupable : ARR=0 → compteur ms FIGÉ → anti-rebond dépendait du temps
+• Leçon : le symptôme n'est jamais là où est la cause
+AFFAIRE 2 — L'ADRESSE FANTÔME
+• Symptôme : scan I2C vide (127 adresses, silence total)
+• Alim OK, connexions OK, config OK... 
+• Coupable : firmware sur PB6/PB7, shield sur PB8/PB9 → "on criait dans une pièce vide"
+• Leçon : lire le schéma du SHIELD, pas juste la datasheet MCU
+AFFAIRE 3 — L'INSTANT MANQUÉ
+• Symptôme : détection 1 saut sur 3 → démo impossible
+• UART révèle : échantillonnage 10 ms trop lent → rate creux + pic
+• Fix : 416 Hz + lecture chaque tour + afficheur figé pendant vol
+• Leçon/méthode : ISOLER, MESURER, PROUVER — printf = stéthoscope</a:t>
             </a:r>
             <a:endParaRPr lang="en-US" dirty="0"/>
           </a:p>
@@ -859,7 +892,20 @@
           <a:p>
             <a:r>
               <a:rPr lang="en-US" dirty="0"/>
-              <a:t>Mettez en scène la formule h = g·t²/8 : un chronomètre devient un instrument de mesure de hauteur. Lisez la courbe : chute vers 0 g au décollage, pic à l'impact. Puis la machine à états, de haut en bas, EN L'AIR en surbrillance.</a:t>
+              <a:t>SLIDE 04 — RÉSOLUTION (4min)
+FORMULE h = g·t²/8
+• Cinématique : vol = 2 moitiés symétriques (t/2 montée, t/2 descente)
+• Chute depuis sommet : h = ½g(t/2)² = g·t²/8
+• Remarquable : dépend QUE du temps (pas masse, pas technique)
+• Exemples : 500 ms → ~30 cm / 640 ms → ~50 cm
+• 1 ms de précision sur t → ~1 mm sur h
+COURBE ACCÉLÉRATION (lire de gauche à droite)
+• Repos = 1 g → impulsion (pic bref) → CHUTE VERS 0 g = départ chrono
+• Plateau apesanteur = tout le vol
+• Pic impact &gt;&gt; 1 g = arrêt chrono
+• 2 seuils : bas (décollage) + haut (impact) → simple, robuste, sans dérive
+MACHINE À ÉTATS
+• SETUP (potentiomètre) → PRÊT (validé bouton) → EN L'AIR (chrono) → RÉSULTAT (h + vibration) → retour SETUP</a:t>
             </a:r>
             <a:endParaRPr lang="en-US" dirty="0"/>
           </a:p>
@@ -947,7 +993,13 @@
           <a:p>
             <a:r>
               <a:rPr lang="en-US" dirty="0"/>
-              <a:t>Récapitulez les trois coches, lâchez la phrase d'accroche, évoquez les évolutions, puis enchaînez immédiatement sur la démo live — sautez devant le jury.</a:t>
+              <a:t>SLIDE 05 — CONCLUSION (2min) + DÉMO
+• Punchline : "On ne mesure pas le saut, on mesure le silence de la chute"
+• 3 acquis : objectif réglable / détection fiable / verdict + vibration
+• Leçon méthode : isoler, mesurer, prouver
+• Évolutions : EEPROM (progression) / courbe live UART / multi-joueurs
+• → DÉMO LIVE : régler, valider, SAUTER devant le jury
+• "Merci, prêts pour vos questions"</a:t>
             </a:r>
             <a:endParaRPr lang="en-US" dirty="0"/>
           </a:p>

</xml_diff>